<commit_message>
Publish OmNi-Ledger Judge Edition v3.0.10
</commit_message>
<xml_diff>
--- a/PITCH_DECK.pptx
+++ b/PITCH_DECK.pptx
@@ -10248,7 +10248,7 @@
                 </a:solidFill>
                 <a:latin typeface="Arial"/>
               </a:rPr>
-              <a:t>Must be verified with account access</a:t>
+              <a:t>Live AMD runs on Token Factory</a:t>
             </a:r>
           </a:p>
         </p:txBody>
@@ -10290,7 +10290,7 @@
                 </a:solidFill>
                 <a:latin typeface="Arial"/>
               </a:rPr>
-              <a:t>Live Gemma inference through the exact AMD model endpoint, and the current deployed judge URL after publishing this new build.</a:t>
+              <a:t>Owner-run CLI requests with Gemma: valid invoice ACCEPTED, expired invoice BLOCKED (EXPIRED_GOODS). IDs in LIVE_RUN_EVIDENCE.md.</a:t>
             </a:r>
           </a:p>
         </p:txBody>
@@ -10332,7 +10332,7 @@
                 </a:solidFill>
                 <a:latin typeface="Arial"/>
               </a:rPr>
-              <a:t>LIVE CREDENTIALS / DEPLOYMENT</a:t>
+              <a:t>OWNER-CAPTURED EVIDENCE</a:t>
             </a:r>
           </a:p>
         </p:txBody>

</xml_diff>